<commit_message>
Made the dashboard demo predictable: links jam only where clicked, with countdown badges, a clear button and per-flow events
</commit_message>
<xml_diff>
--- a/docs/Final_Review.pptx
+++ b/docs/Final_Review.pptx
@@ -5531,7 +5531,7 @@
                 <a:ea typeface="Calibri" pitchFamily="34" charset="-122"/>
                 <a:cs typeface="Calibri" pitchFamily="34" charset="-120"/>
               </a:rPr>
-              <a:t>Congest AS200 backbone</a:t>
+              <a:t>Jam backbone (or click a link)</a:t>
             </a:r>
             <a:endParaRPr lang="en-US" sz="1300" dirty="0"/>
           </a:p>
@@ -5570,7 +5570,7 @@
                 <a:ea typeface="Calibri" pitchFamily="34" charset="-122"/>
                 <a:cs typeface="Calibri" pitchFamily="34" charset="-120"/>
               </a:rPr>
-              <a:t>Link turns red; OSPF’s quality collapses</a:t>
+              <a:t>Only that road turns red; OSPF’s quality collapses</a:t>
             </a:r>
             <a:endParaRPr lang="en-US" sz="1100" dirty="0"/>
           </a:p>

</xml_diff>